<commit_message>
docs: cap nhat PPTX bao cao tien do - panel Tuan 6 (76,3%, 29/38 buoc)
</commit_message>
<xml_diff>
--- a/docs/teaching-notes/bao-cao-tuan/Bao_cao_tien_do_Tuan_LACCO.pptx
+++ b/docs/teaching-notes/bao-cao-tuan/Bao_cao_tien_do_Tuan_LACCO.pptx
@@ -757,7 +757,7 @@
                 <a:ea typeface="Arial" pitchFamily="34" charset="-122"/>
                 <a:cs typeface="Arial" pitchFamily="34" charset="-120"/>
               </a:rPr>
-              <a:t>Giai đoạn 1 (WebApp MVP · 8 tuần)  ·  Cập nhật Tuần 5 — 09/09/2026</a:t>
+              <a:t>Giai đoạn 1 (WebApp MVP · 8 tuần)  ·  Cập nhật Tuần 6 — 13/09/2026</a:t>
             </a:r>
             <a:endParaRPr lang="en-US" sz="1200" dirty="0"/>
           </a:p>
@@ -825,7 +825,7 @@
                 <a:ea typeface="Arial" pitchFamily="34" charset="-122"/>
                 <a:cs typeface="Arial" pitchFamily="34" charset="-120"/>
               </a:rPr>
-              <a:t>65,8%</a:t>
+              <a:t>76,3%</a:t>
             </a:r>
             <a:endParaRPr lang="en-US" sz="2700" dirty="0"/>
           </a:p>
@@ -864,7 +864,7 @@
                 <a:ea typeface="Arial" pitchFamily="34" charset="-122"/>
                 <a:cs typeface="Arial" pitchFamily="34" charset="-120"/>
               </a:rPr>
-              <a:t>Toàn dự án · 25/38 bước</a:t>
+              <a:t>Toàn dự án · 29/38 bước</a:t>
             </a:r>
             <a:endParaRPr lang="en-US" sz="900" dirty="0"/>
           </a:p>
@@ -971,7 +971,7 @@
                 <a:ea typeface="Arial" pitchFamily="34" charset="-122"/>
                 <a:cs typeface="Arial" pitchFamily="34" charset="-120"/>
               </a:rPr>
-              <a:t>Tuần 5 · 4/4 bước</a:t>
+              <a:t>Tuần 6 · 4/4 bước</a:t>
             </a:r>
             <a:endParaRPr lang="en-US" sz="900" dirty="0"/>
           </a:p>
@@ -2589,7 +2589,7 @@
                 <a:ea typeface="Arial" pitchFamily="34" charset="-122"/>
                 <a:cs typeface="Arial" pitchFamily="34" charset="-120"/>
               </a:rPr>
-              <a:t>TUẦN 5 — CHI TIẾT 4 BƯỚC</a:t>
+              <a:t>TUẦN 6 — CHI TIẾT 4 BƯỚC</a:t>
             </a:r>
             <a:endParaRPr lang="en-US" sz="1300" dirty="0"/>
           </a:p>
@@ -2694,7 +2694,7 @@
                 <a:ea typeface="Arial" pitchFamily="34" charset="-122"/>
                 <a:cs typeface="Arial" pitchFamily="34" charset="-120"/>
               </a:rPr>
-              <a:t>5.1  Chạy song song 4 module báo cáo (2 đợt x 2 report-builder-agent)</a:t>
+              <a:t>6.1  Xuất báo cáo Excel/PDF (ReportLab, kaleido, graceful fallback)</a:t>
             </a:r>
             <a:endParaRPr lang="en-US" sz="1100" dirty="0"/>
           </a:p>
@@ -2799,7 +2799,7 @@
                 <a:ea typeface="Arial" pitchFamily="34" charset="-122"/>
                 <a:cs typeface="Arial" pitchFamily="34" charset="-120"/>
               </a:rPr>
-              <a:t>5.2  Đồng bộ tài liệu kiến trúc SDD.md/README (doc-writer-agent)</a:t>
+              <a:t>6.2  Test tải 20 người dùng đồng thời (tầng Service/DB, p95&lt;3s)</a:t>
             </a:r>
             <a:endParaRPr lang="en-US" sz="1100" dirty="0"/>
           </a:p>
@@ -2904,7 +2904,7 @@
                 <a:ea typeface="Arial" pitchFamily="34" charset="-122"/>
                 <a:cs typeface="Arial" pitchFamily="34" charset="-120"/>
               </a:rPr>
-              <a:t>5.3  Checkpoint giữa dự án: đối chiếu tiến độ thực tế vs kế hoạch</a:t>
+              <a:t>6.3  Cấu hình Sentry giám sát lỗi runtime (SaaS free tier)</a:t>
             </a:r>
             <a:endParaRPr lang="en-US" sz="1100" dirty="0"/>
           </a:p>
@@ -3009,7 +3009,7 @@
                 <a:ea typeface="Arial" pitchFamily="34" charset="-122"/>
                 <a:cs typeface="Arial" pitchFamily="34" charset="-120"/>
               </a:rPr>
-              <a:t>5.4  Review &amp; nhật ký Tuần 5</a:t>
+              <a:t>6.4  Review &amp; nhật ký Tuần 6</a:t>
             </a:r>
             <a:endParaRPr lang="en-US" sz="1100" dirty="0"/>
           </a:p>
@@ -3130,7 +3130,7 @@
                 <a:ea typeface="Arial" pitchFamily="34" charset="-122"/>
                 <a:cs typeface="Arial" pitchFamily="34" charset="-120"/>
               </a:rPr>
-              <a:t>Tất cả 5/5 nhóm báo cáo Giai đoạn 1 đã hoạt động (Kinh doanh, Khách hàng, Pricing, Chi phí, Công nợ) — đạt tiêu chí nghiệm thu MVP #1 về tính năng; CI test coverage cho src/services/ vẫn đang là 0%</a:t>
+              <a:t>Bước 6.1 (Excel/PDF) và 6.2 (test tải) đạt đúng tiêu chí nghiệm thu MVP #4 và #5 (Kế hoạch triển khai mục 8); bước 6.3 (Sentry) không thuộc tiêu chí nghiệm thu gốc nhưng bổ sung giám sát lỗi runtime trước go-live — cả 3 bước đều phát sinh vướng mắc kỹ thuật thật, đã xử lý và ghi đầy đủ ở HD-18/19/20</a:t>
             </a:r>
             <a:endParaRPr lang="en-US" sz="1100" dirty="0"/>
           </a:p>
@@ -3154,7 +3154,7 @@
                 <a:ea typeface="Arial" pitchFamily="34" charset="-122"/>
                 <a:cs typeface="Arial" pitchFamily="34" charset="-120"/>
               </a:rPr>
-              <a:t>Khuyến nghị từ checkpoint bước 5.3: ưu tiên xử lý bảo mật (MySQL least-privilege user, _DEV_FALLBACK_COOKIE_KEY) TRƯỚC bước 7.2 (Deploy Windows Server); bổ sung test coverage cho report_*.py/admin_actions.py trước/trong bước 7.1 (Test suite cuối)</a:t>
+              <a:t>3 rủi ro môi trường mang sang bước 7.2 (Deploy Windows Server): (a) kaleido/Chrome headless chưa xác nhận ổn định ngoài máy dev, (b) dịch vụ MySQL80 cần xác nhận tự khởi động cùng Windows, (c) test tải 6.2 mới đo trên dữ liệu mẫu nhỏ, nên đo lại gần sát dữ liệu thật hơn</a:t>
             </a:r>
             <a:endParaRPr lang="en-US" sz="1100" dirty="0"/>
           </a:p>
@@ -3178,7 +3178,7 @@
                 <a:ea typeface="Arial" pitchFamily="34" charset="-122"/>
                 <a:cs typeface="Arial" pitchFamily="34" charset="-120"/>
               </a:rPr>
-              <a:t>Tiến độ theo lịch (không phải nội dung) trễ ổn định ~2 tuần kể từ Tuần 1, không có dấu hiệu trễ thêm — không cần rush hay cắt phạm vi (tracker coi ngày là mốc linh hoạt, không phải deadline cứng)</a:t>
+              <a:t>Tồn đọng từ Tuần 5 CHƯA xử lý: test coverage src/services/ vẫn 0%; khuyến nghị bảo mật (MySQL least-privilege user, _DEV_FALLBACK_COOKIE_KEY) vẫn chưa làm — ưu tiên trước/trong bước 7.1 (Test suite &amp; security review cuối)</a:t>
             </a:r>
             <a:endParaRPr lang="en-US" sz="1100" dirty="0"/>
           </a:p>
@@ -3202,7 +3202,7 @@
                 <a:ea typeface="Arial" pitchFamily="34" charset="-122"/>
                 <a:cs typeface="Arial" pitchFamily="34" charset="-120"/>
               </a:rPr>
-              <a:t>Tồn đọng: một số mục erd-tuan-02.md/SDD.md còn mở (không chặn tiến độ, xử lý khi thuận tiện); tuỳ chọn (không bắt buộc) cập nhật lại ngày dự kiến Tuần 6-8 trong tracker cho khớp độ trễ quan sát được</a:t>
+              <a:t>Tiến độ theo lịch (không phải nội dung) tiếp tục trễ ổn định so với mốc dự kiến, không có dấu hiệu trễ thêm — không cần rush hay cắt phạm vi (tracker coi ngày là mốc linh hoạt, không phải deadline cứng)</a:t>
             </a:r>
             <a:endParaRPr lang="en-US" sz="1100" dirty="0"/>
           </a:p>
@@ -3421,6 +3421,74 @@
         <p:spPr>
           <a:xfrm>
             <a:off x="6258416" y="3182112"/>
+            <a:ext cx="1133856" cy="237744"/>
+          </a:xfrm>
+          <a:prstGeom prst="rect">
+            <a:avLst/>
+          </a:prstGeom>
+          <a:noFill/>
+          <a:ln/>
+        </p:spPr>
+        <p:txBody>
+          <a:bodyPr wrap="square" lIns="0" tIns="0" rIns="0" bIns="0" rtlCol="0" anchor="ctr"/>
+          <a:lstStyle/>
+          <a:p>
+            <a:pPr marL="0" indent="0" algn="ctr">
+              <a:buNone/>
+            </a:pPr>
+            <a:r>
+              <a:rPr lang="en-US" sz="850" b="1" dirty="0">
+                <a:solidFill>
+                  <a:srgbClr val="FFFFFF"/>
+                </a:solidFill>
+                <a:latin typeface="Arial" pitchFamily="34" charset="0"/>
+                <a:ea typeface="Arial" pitchFamily="34" charset="-122"/>
+                <a:cs typeface="Arial" pitchFamily="34" charset="-120"/>
+              </a:rPr>
+              <a:t>Hoàn thành · 100%</a:t>
+            </a:r>
+            <a:endParaRPr lang="en-US" sz="850" dirty="0"/>
+          </a:p>
+        </p:txBody>
+      </p:sp>
+      <p:sp>
+        <p:nvSpPr>
+          <p:cNvPr id="6017" name="Shape 15 (Tuan6)"/>
+          <p:cNvSpPr/>
+          <p:nvPr/>
+        </p:nvSpPr>
+        <p:spPr>
+          <a:xfrm>
+            <a:off x="7701862" y="3182112"/>
+            <a:ext cx="1133856" cy="237744"/>
+          </a:xfrm>
+          <a:prstGeom prst="roundRect">
+            <a:avLst>
+              <a:gd name="adj" fmla="val 23077"/>
+            </a:avLst>
+          </a:prstGeom>
+          <a:solidFill>
+            <a:srgbClr val="2E8B57"/>
+          </a:solidFill>
+          <a:ln/>
+        </p:spPr>
+        <p:txBody>
+          <a:bodyPr/>
+          <a:lstStyle/>
+          <a:p>
+            <a:endParaRPr lang="en-US"/>
+          </a:p>
+        </p:txBody>
+      </p:sp>
+      <p:sp>
+        <p:nvSpPr>
+          <p:cNvPr id="6019" name="Text 16 (Tuan6)"/>
+          <p:cNvSpPr/>
+          <p:nvPr/>
+        </p:nvSpPr>
+        <p:spPr>
+          <a:xfrm>
+            <a:off x="7701862" y="3182112"/>
             <a:ext cx="1133856" cy="237744"/>
           </a:xfrm>
           <a:prstGeom prst="rect">

</xml_diff>

<commit_message>
docs: nhat ky Tuan 7 + cap nhat slide bao cao tien do (buoc 7.4, chot Tuan 7)
Co-Authored-By: Claude Sonnet 5 <noreply@anthropic.com>
Claude-Session: https://claude.ai/code/session_01SKQSe62E9cQXdPELtrxjsA
</commit_message>
<xml_diff>
--- a/docs/teaching-notes/bao-cao-tuan/Bao_cao_tien_do_Tuan_LACCO.pptx
+++ b/docs/teaching-notes/bao-cao-tuan/Bao_cao_tien_do_Tuan_LACCO.pptx
@@ -757,7 +757,7 @@
                 <a:ea typeface="Arial" pitchFamily="34" charset="-122"/>
                 <a:cs typeface="Arial" pitchFamily="34" charset="-120"/>
               </a:rPr>
-              <a:t>Giai đoạn 1 (WebApp MVP · 8 tuần)  ·  Cập nhật Tuần 6 — 13/09/2026</a:t>
+              <a:t>Giai đoạn 1 (WebApp MVP · 8 tuần)  ·  Cập nhật Tuần 7 — 20/10/2026</a:t>
             </a:r>
             <a:endParaRPr lang="en-US" sz="1200" dirty="0"/>
           </a:p>
@@ -825,7 +825,7 @@
                 <a:ea typeface="Arial" pitchFamily="34" charset="-122"/>
                 <a:cs typeface="Arial" pitchFamily="34" charset="-120"/>
               </a:rPr>
-              <a:t>76,3%</a:t>
+              <a:t>86,8%</a:t>
             </a:r>
             <a:endParaRPr lang="en-US" sz="2700" dirty="0"/>
           </a:p>
@@ -864,7 +864,7 @@
                 <a:ea typeface="Arial" pitchFamily="34" charset="-122"/>
                 <a:cs typeface="Arial" pitchFamily="34" charset="-120"/>
               </a:rPr>
-              <a:t>Toàn dự án · 29/38 bước</a:t>
+              <a:t>Toàn dự án · 33/38 bước</a:t>
             </a:r>
             <a:endParaRPr lang="en-US" sz="900" dirty="0"/>
           </a:p>
@@ -971,7 +971,7 @@
                 <a:ea typeface="Arial" pitchFamily="34" charset="-122"/>
                 <a:cs typeface="Arial" pitchFamily="34" charset="-120"/>
               </a:rPr>
-              <a:t>Tuần 6 · 4/4 bước</a:t>
+              <a:t>Tuần 7 · 4/4 bước</a:t>
             </a:r>
             <a:endParaRPr lang="en-US" sz="900" dirty="0"/>
           </a:p>
@@ -2589,7 +2589,7 @@
                 <a:ea typeface="Arial" pitchFamily="34" charset="-122"/>
                 <a:cs typeface="Arial" pitchFamily="34" charset="-120"/>
               </a:rPr>
-              <a:t>TUẦN 6 — CHI TIẾT 4 BƯỚC</a:t>
+              <a:t>TUẦN 7 — CHI TIẾT 4 BƯỚC</a:t>
             </a:r>
             <a:endParaRPr lang="en-US" sz="1300" dirty="0"/>
           </a:p>
@@ -2694,7 +2694,7 @@
                 <a:ea typeface="Arial" pitchFamily="34" charset="-122"/>
                 <a:cs typeface="Arial" pitchFamily="34" charset="-120"/>
               </a:rPr>
-              <a:t>6.1  Xuất báo cáo Excel/PDF (ReportLab, kaleido, graceful fallback)</a:t>
+              <a:t>7.1  Test suite &amp; security review cuối (175 test, 88% coverage, Fix A + Fix B)</a:t>
             </a:r>
             <a:endParaRPr lang="en-US" sz="1100" dirty="0"/>
           </a:p>
@@ -2799,7 +2799,7 @@
                 <a:ea typeface="Arial" pitchFamily="34" charset="-122"/>
                 <a:cs typeface="Arial" pitchFamily="34" charset="-120"/>
               </a:rPr>
-              <a:t>6.2  Test tải 20 người dùng đồng thời (tầng Service/DB, p95&lt;3s)</a:t>
+              <a:t>7.2  Deploy Windows Server (Windows Service qua Task Scheduler)</a:t>
             </a:r>
             <a:endParaRPr lang="en-US" sz="1100" dirty="0"/>
           </a:p>
@@ -2904,7 +2904,7 @@
                 <a:ea typeface="Arial" pitchFamily="34" charset="-122"/>
                 <a:cs typeface="Arial" pitchFamily="34" charset="-120"/>
               </a:rPr>
-              <a:t>6.3  Cấu hình Sentry giám sát lỗi runtime (SaaS free tier)</a:t>
+              <a:t>7.3  Backup/restore MySQL định kỳ (mysqldump + Task Scheduler + OneDrive)</a:t>
             </a:r>
             <a:endParaRPr lang="en-US" sz="1100" dirty="0"/>
           </a:p>
@@ -3009,7 +3009,7 @@
                 <a:ea typeface="Arial" pitchFamily="34" charset="-122"/>
                 <a:cs typeface="Arial" pitchFamily="34" charset="-120"/>
               </a:rPr>
-              <a:t>6.4  Review &amp; nhật ký Tuần 6</a:t>
+              <a:t>7.4  Review &amp; nhật ký Tuần 7</a:t>
             </a:r>
             <a:endParaRPr lang="en-US" sz="1100" dirty="0"/>
           </a:p>
@@ -3130,7 +3130,7 @@
                 <a:ea typeface="Arial" pitchFamily="34" charset="-122"/>
                 <a:cs typeface="Arial" pitchFamily="34" charset="-120"/>
               </a:rPr>
-              <a:t>Bước 6.1 (Excel/PDF) và 6.2 (test tải) đạt đúng tiêu chí nghiệm thu MVP #4 và #5 (Kế hoạch triển khai mục 8); bước 6.3 (Sentry) không thuộc tiêu chí nghiệm thu gốc nhưng bổ sung giám sát lỗi runtime trước go-live — cả 3 bước đều phát sinh vướng mắc kỹ thuật thật, đã xử lý và ghi đầy đủ ở HD-18/19/20</a:t>
+              <a:t>Bước 7.3 (Backup/restore) đạt đúng tiêu chí nghiệm thu MVP #6 (Kế hoạch triển khai mục 8); 7.1 (test suite + security) và 7.2 (deploy Windows) không thuộc tiêu chí nghiệm thu gốc nhưng củng cố bảo mật và vận hành trước go-live — cả 3 bước đều phát sinh vướng mắc kỹ thuật thật, đã xử lý và ghi đầy đủ ở HD-21/22/23</a:t>
             </a:r>
             <a:endParaRPr lang="en-US" sz="1100" dirty="0"/>
           </a:p>
@@ -3154,7 +3154,7 @@
                 <a:ea typeface="Arial" pitchFamily="34" charset="-122"/>
                 <a:cs typeface="Arial" pitchFamily="34" charset="-120"/>
               </a:rPr>
-              <a:t>3 rủi ro môi trường mang sang bước 7.2 (Deploy Windows Server): (a) kaleido/Chrome headless chưa xác nhận ổn định ngoài máy dev, (b) dịch vụ MySQL80 cần xác nhận tự khởi động cùng Windows, (c) test tải 6.2 mới đo trên dữ liệu mẫu nhỏ, nên đo lại gần sát dữ liệu thật hơn</a:t>
+              <a:t>Tồn đọng từ Tuần 6 ĐÃ xử lý ở bước 7.1: test coverage src/services/ từ 0% lên 88%; 2 khuyến nghị bảo mật (MySQL least-privilege, bỏ cookie key hardcode) đã làm xong</a:t>
             </a:r>
             <a:endParaRPr lang="en-US" sz="1100" dirty="0"/>
           </a:p>
@@ -3178,7 +3178,7 @@
                 <a:ea typeface="Arial" pitchFamily="34" charset="-122"/>
                 <a:cs typeface="Arial" pitchFamily="34" charset="-120"/>
               </a:rPr>
-              <a:t>Tồn đọng từ Tuần 5 CHƯA xử lý: test coverage src/services/ vẫn 0%; khuyến nghị bảo mật (MySQL least-privilege user, _DEV_FALLBACK_COOKIE_KEY) vẫn chưa làm — ưu tiên trước/trong bước 7.1 (Test suite &amp; security review cuối)</a:t>
+              <a:t>Rủi ro mang sang Tuần 8/UAT: máy hiện tại vừa dev vừa production, nên tách khi có điều kiện; 2 hạng mục hoãn theo quyết định COO (PDF có chart kaleido, load test khối lượng lớn) chưa chặn go-live</a:t>
             </a:r>
             <a:endParaRPr lang="en-US" sz="1100" dirty="0"/>
           </a:p>
@@ -3489,6 +3489,74 @@
         <p:spPr>
           <a:xfrm>
             <a:off x="7701862" y="3182112"/>
+            <a:ext cx="1133856" cy="237744"/>
+          </a:xfrm>
+          <a:prstGeom prst="rect">
+            <a:avLst/>
+          </a:prstGeom>
+          <a:noFill/>
+          <a:ln/>
+        </p:spPr>
+        <p:txBody>
+          <a:bodyPr wrap="square" lIns="0" tIns="0" rIns="0" bIns="0" rtlCol="0" anchor="ctr"/>
+          <a:lstStyle/>
+          <a:p>
+            <a:pPr marL="0" indent="0" algn="ctr">
+              <a:buNone/>
+            </a:pPr>
+            <a:r>
+              <a:rPr lang="en-US" sz="850" b="1" dirty="0">
+                <a:solidFill>
+                  <a:srgbClr val="FFFFFF"/>
+                </a:solidFill>
+                <a:latin typeface="Arial" pitchFamily="34" charset="0"/>
+                <a:ea typeface="Arial" pitchFamily="34" charset="-122"/>
+                <a:cs typeface="Arial" pitchFamily="34" charset="-120"/>
+              </a:rPr>
+              <a:t>Hoàn thành · 100%</a:t>
+            </a:r>
+            <a:endParaRPr lang="en-US" sz="850" dirty="0"/>
+          </a:p>
+        </p:txBody>
+      </p:sp>
+      <p:sp>
+        <p:nvSpPr>
+          <p:cNvPr id="7017" name="Shape 15 (Tuan7)"/>
+          <p:cNvSpPr/>
+          <p:nvPr/>
+        </p:nvSpPr>
+        <p:spPr>
+          <a:xfrm>
+            <a:off x="9036231" y="3182112"/>
+            <a:ext cx="1133856" cy="237744"/>
+          </a:xfrm>
+          <a:prstGeom prst="roundRect">
+            <a:avLst>
+              <a:gd name="adj" fmla="val 23077"/>
+            </a:avLst>
+          </a:prstGeom>
+          <a:solidFill>
+            <a:srgbClr val="2E8B57"/>
+          </a:solidFill>
+          <a:ln/>
+        </p:spPr>
+        <p:txBody>
+          <a:bodyPr/>
+          <a:lstStyle/>
+          <a:p>
+            <a:endParaRPr lang="en-US"/>
+          </a:p>
+        </p:txBody>
+      </p:sp>
+      <p:sp>
+        <p:nvSpPr>
+          <p:cNvPr id="7019" name="Text 16 (Tuan7)"/>
+          <p:cNvSpPr/>
+          <p:nvPr/>
+        </p:nvSpPr>
+        <p:spPr>
+          <a:xfrm>
+            <a:off x="9036231" y="3182112"/>
             <a:ext cx="1133856" cy="237744"/>
           </a:xfrm>
           <a:prstGeom prst="rect">

</xml_diff>